<commit_message>
docs(report): add v0.4 AI engineering deck
</commit_message>
<xml_diff>
--- a/docs/report/ai-redefines-software-development-presentation/ai-redefines-software-development-v0.3.pptx
+++ b/docs/report/ai-redefines-software-development-presentation/ai-redefines-software-development-v0.3.pptx
@@ -1444,12 +1444,12 @@
           <a:p>
             <a:r>
               <a:rPr lang="en-US" dirty="0"/>
-              <a:t>第 7 页：速度放大之后，质量责任被重新定义
-建议时长：约 1.0 分钟
-页内重点：解释从能跑到可放行的距离，承接前一页证据放行机制。
-互动提问：AI 生成的代码能跑之后，距离可合并、可发布、可长期维护还差什么？
-讲稿：当速度被放大之后，质量责任会从“这个功能能不能跑”扩展到“谁确认它可以进入系统”。功能能跑，只说明 happy path 暂时成立；设计不沉淀，意味着需求变化没有变成可复用的决策记录；协作被压缩，意味着个人加 Agent 很快，但团队共识可能不足；修复凭自信，意味着 Agent 可以给出看似合理的 patch，却没有复现、日志和验证。这里的关键是把“高置信度”从模型自信改成工程证据：证据不是附属材料，而是进入合并、发布和复盘的主路径。
-转场：质量责任落地以后，工程治理需要从门禁转向更细的智能护栏。</a:t>
+              <a:t>第 7 页：速度的代价：把返工变成可管理队列
+建议时长：约 1.3 分钟
+页内重点：把速度提升后的隐形成本落到可执行的度量、分流和修复闭环。
+互动提问：当 AI 让代码进入仓库的速度变快，团队怎样避免 review、返工和集成变成新瓶颈？
+讲稿：前一页说速度收益不是指数曲线，这一页回答“代价该怎么处理”。AI 让写代码变快以后，新的瓶颈通常不是打字速度，而是 review 队列、返工循环、CI 不稳定、跨团队集成和线上恢复。第一步要把成本显性化：不要只看生成了多少代码，而要看从需求到可验证结果的净时间、PR 等待、返工率、失败重跑、MTTR。METR 的开源开发者实验提醒我们，熟悉项目里使用 AI 也可能变慢；Harness 的报告则说明，评审、修 bug、工具切换会成为隐形工作。第二步是入口风险分流：不是所有 AI 变更都走同一条审批线，而是按 owner、diff 大小、模块热度、SLO 影响做风险打标，低风险自动验证，高风险进入设计和人工评审。第三步是闭环修复：SWE-CI 把 Agent 评估放进连续集成循环，SWE-PRBench 提醒 AI 评审还不能当最终裁决，AgentTrace 和 AgentRx 这类工作则把失败步骤和根因变成可定位对象。这样速度提升才不会把成本甩给最后一个 reviewer，而是进入一个可度量、可分流、可修复的工程队列。
+转场：把代价管住以后，下一步才是讨论开源和大厂场景下的质量治理形态。</a:t>
             </a:r>
             <a:endParaRPr lang="en-US" dirty="0"/>
           </a:p>

</xml_diff>